<commit_message>
Update PowerPoint for song #18 in FUBC - Українські
</commit_message>
<xml_diff>
--- a/fubc-ua/18-Царю вічний наш, Єгово (Пісні Спасенних №16).pptx
+++ b/fubc-ua/18-Царю вічний наш, Єгово (Пісні Спасенних №16).pptx
@@ -2069,23 +2069,6 @@
             </a:r>
             <a:endParaRPr lang="en-US" sz="4800" dirty="0"/>
           </a:p>
-          <a:p>
-            <a:pPr algn="ctr" indent="0" marL="0">
-              <a:buNone/>
-            </a:pPr>
-            <a:r>
-              <a:rPr lang="en-US" sz="4800" b="1" dirty="0">
-                <a:solidFill>
-                  <a:srgbClr val="FFFFFF"/>
-                </a:solidFill>
-                <a:latin typeface="Arial" pitchFamily="34" charset="0"/>
-                <a:ea typeface="Arial" pitchFamily="34" charset="-122"/>
-                <a:cs typeface="Arial" pitchFamily="34" charset="-120"/>
-              </a:rPr>
-              <a:t>(Пісні Спасенних №16)</a:t>
-            </a:r>
-            <a:endParaRPr lang="en-US" sz="4800" dirty="0"/>
-          </a:p>
         </p:txBody>
       </p:sp>
     </p:spTree>
@@ -2153,24 +2136,7 @@
                 <a:ea typeface="Arial" pitchFamily="34" charset="-122"/>
                 <a:cs typeface="Arial" pitchFamily="34" charset="-120"/>
               </a:rPr>
-              <a:t>дай нам (хліб небесний),</a:t>
-            </a:r>
-            <a:endParaRPr lang="en-US" sz="4800" dirty="0"/>
-          </a:p>
-          <a:p>
-            <a:pPr algn="ctr" indent="0" marL="0">
-              <a:buNone/>
-            </a:pPr>
-            <a:r>
-              <a:rPr lang="en-US" sz="4800" b="1" i="1" dirty="0">
-                <a:solidFill>
-                  <a:srgbClr val="FFFFFF"/>
-                </a:solidFill>
-                <a:latin typeface="Arial" pitchFamily="34" charset="0"/>
-                <a:ea typeface="Arial" pitchFamily="34" charset="-122"/>
-                <a:cs typeface="Arial" pitchFamily="34" charset="-120"/>
-              </a:rPr>
-              <a:t>дай нам (хліб небесний) –</a:t>
+              <a:t>дай нам, дай нам –</a:t>
             </a:r>
             <a:endParaRPr lang="en-US" sz="4800" dirty="0"/>
           </a:p>
@@ -2453,24 +2419,7 @@
                 <a:ea typeface="Arial" pitchFamily="34" charset="-122"/>
                 <a:cs typeface="Arial" pitchFamily="34" charset="-120"/>
               </a:rPr>
-              <a:t>Дай нам (хліб небесний),</a:t>
-            </a:r>
-            <a:endParaRPr lang="en-US" sz="4800" dirty="0"/>
-          </a:p>
-          <a:p>
-            <a:pPr algn="ctr" indent="0" marL="0">
-              <a:buNone/>
-            </a:pPr>
-            <a:r>
-              <a:rPr lang="en-US" sz="4800" b="1" i="1" dirty="0">
-                <a:solidFill>
-                  <a:srgbClr val="FFFFFF"/>
-                </a:solidFill>
-                <a:latin typeface="Arial" pitchFamily="34" charset="0"/>
-                <a:ea typeface="Arial" pitchFamily="34" charset="-122"/>
-                <a:cs typeface="Arial" pitchFamily="34" charset="-120"/>
-              </a:rPr>
-              <a:t>дай нам (хліб небесний),</a:t>
+              <a:t>Дай нам, дай нам,</a:t>
             </a:r>
             <a:endParaRPr lang="en-US" sz="4800" dirty="0"/>
           </a:p>
@@ -2580,24 +2529,7 @@
                 <a:ea typeface="Arial" pitchFamily="34" charset="-122"/>
                 <a:cs typeface="Arial" pitchFamily="34" charset="-120"/>
               </a:rPr>
-              <a:t>дай нам (хліб небесний),</a:t>
-            </a:r>
-            <a:endParaRPr lang="en-US" sz="4800" dirty="0"/>
-          </a:p>
-          <a:p>
-            <a:pPr algn="ctr" indent="0" marL="0">
-              <a:buNone/>
-            </a:pPr>
-            <a:r>
-              <a:rPr lang="en-US" sz="4800" b="1" i="1" dirty="0">
-                <a:solidFill>
-                  <a:srgbClr val="FFFFFF"/>
-                </a:solidFill>
-                <a:latin typeface="Arial" pitchFamily="34" charset="0"/>
-                <a:ea typeface="Arial" pitchFamily="34" charset="-122"/>
-                <a:cs typeface="Arial" pitchFamily="34" charset="-120"/>
-              </a:rPr>
-              <a:t>дай нам (хліб небесний) –</a:t>
+              <a:t>дай нам, дай нам –</a:t>
             </a:r>
             <a:endParaRPr lang="en-US" sz="4800" dirty="0"/>
           </a:p>
@@ -2951,24 +2883,7 @@
                 <a:ea typeface="Arial" pitchFamily="34" charset="-122"/>
                 <a:cs typeface="Arial" pitchFamily="34" charset="-120"/>
               </a:rPr>
-              <a:t>Дай нам (хліб небесний),</a:t>
-            </a:r>
-            <a:endParaRPr lang="en-US" sz="4800" dirty="0"/>
-          </a:p>
-          <a:p>
-            <a:pPr algn="ctr" indent="0" marL="0">
-              <a:buNone/>
-            </a:pPr>
-            <a:r>
-              <a:rPr lang="en-US" sz="4800" b="1" i="1" dirty="0">
-                <a:solidFill>
-                  <a:srgbClr val="FFFFFF"/>
-                </a:solidFill>
-                <a:latin typeface="Arial" pitchFamily="34" charset="0"/>
-                <a:ea typeface="Arial" pitchFamily="34" charset="-122"/>
-                <a:cs typeface="Arial" pitchFamily="34" charset="-120"/>
-              </a:rPr>
-              <a:t>дай нам (хліб небесний),</a:t>
+              <a:t>Дай нам, дай нам,</a:t>
             </a:r>
             <a:endParaRPr lang="en-US" sz="4800" dirty="0"/>
           </a:p>
@@ -3078,24 +2993,7 @@
                 <a:ea typeface="Arial" pitchFamily="34" charset="-122"/>
                 <a:cs typeface="Arial" pitchFamily="34" charset="-120"/>
               </a:rPr>
-              <a:t>дай нам (хліб небесний),</a:t>
-            </a:r>
-            <a:endParaRPr lang="en-US" sz="4800" dirty="0"/>
-          </a:p>
-          <a:p>
-            <a:pPr algn="ctr" indent="0" marL="0">
-              <a:buNone/>
-            </a:pPr>
-            <a:r>
-              <a:rPr lang="en-US" sz="4800" b="1" i="1" dirty="0">
-                <a:solidFill>
-                  <a:srgbClr val="FFFFFF"/>
-                </a:solidFill>
-                <a:latin typeface="Arial" pitchFamily="34" charset="0"/>
-                <a:ea typeface="Arial" pitchFamily="34" charset="-122"/>
-                <a:cs typeface="Arial" pitchFamily="34" charset="-120"/>
-              </a:rPr>
-              <a:t>дай нам (хліб небесний) –</a:t>
+              <a:t>дай нам, дай нам –</a:t>
             </a:r>
             <a:endParaRPr lang="en-US" sz="4800" dirty="0"/>
           </a:p>
@@ -3378,24 +3276,7 @@
                 <a:ea typeface="Arial" pitchFamily="34" charset="-122"/>
                 <a:cs typeface="Arial" pitchFamily="34" charset="-120"/>
               </a:rPr>
-              <a:t>Дай нам (хліб небесний),</a:t>
-            </a:r>
-            <a:endParaRPr lang="en-US" sz="4800" dirty="0"/>
-          </a:p>
-          <a:p>
-            <a:pPr algn="ctr" indent="0" marL="0">
-              <a:buNone/>
-            </a:pPr>
-            <a:r>
-              <a:rPr lang="en-US" sz="4800" b="1" i="1" dirty="0">
-                <a:solidFill>
-                  <a:srgbClr val="FFFFFF"/>
-                </a:solidFill>
-                <a:latin typeface="Arial" pitchFamily="34" charset="0"/>
-                <a:ea typeface="Arial" pitchFamily="34" charset="-122"/>
-                <a:cs typeface="Arial" pitchFamily="34" charset="-120"/>
-              </a:rPr>
-              <a:t>дай нам (хліб небесний),</a:t>
+              <a:t>Дай нам, дай нам,</a:t>
             </a:r>
             <a:endParaRPr lang="en-US" sz="4800" dirty="0"/>
           </a:p>
@@ -3505,24 +3386,7 @@
                 <a:ea typeface="Arial" pitchFamily="34" charset="-122"/>
                 <a:cs typeface="Arial" pitchFamily="34" charset="-120"/>
               </a:rPr>
-              <a:t>дай нам (хліб небесний),</a:t>
-            </a:r>
-            <a:endParaRPr lang="en-US" sz="4800" dirty="0"/>
-          </a:p>
-          <a:p>
-            <a:pPr algn="ctr" indent="0" marL="0">
-              <a:buNone/>
-            </a:pPr>
-            <a:r>
-              <a:rPr lang="en-US" sz="4800" b="1" i="1" dirty="0">
-                <a:solidFill>
-                  <a:srgbClr val="FFFFFF"/>
-                </a:solidFill>
-                <a:latin typeface="Arial" pitchFamily="34" charset="0"/>
-                <a:ea typeface="Arial" pitchFamily="34" charset="-122"/>
-                <a:cs typeface="Arial" pitchFamily="34" charset="-120"/>
-              </a:rPr>
-              <a:t>дай нам (хліб небесний) –</a:t>
+              <a:t>дай нам, дай нам –</a:t>
             </a:r>
             <a:endParaRPr lang="en-US" sz="4800" dirty="0"/>
           </a:p>
@@ -3805,24 +3669,7 @@
                 <a:ea typeface="Arial" pitchFamily="34" charset="-122"/>
                 <a:cs typeface="Arial" pitchFamily="34" charset="-120"/>
               </a:rPr>
-              <a:t>Дай нам (хліб небесний),</a:t>
-            </a:r>
-            <a:endParaRPr lang="en-US" sz="4800" dirty="0"/>
-          </a:p>
-          <a:p>
-            <a:pPr algn="ctr" indent="0" marL="0">
-              <a:buNone/>
-            </a:pPr>
-            <a:r>
-              <a:rPr lang="en-US" sz="4800" b="1" i="1" dirty="0">
-                <a:solidFill>
-                  <a:srgbClr val="FFFFFF"/>
-                </a:solidFill>
-                <a:latin typeface="Arial" pitchFamily="34" charset="0"/>
-                <a:ea typeface="Arial" pitchFamily="34" charset="-122"/>
-                <a:cs typeface="Arial" pitchFamily="34" charset="-120"/>
-              </a:rPr>
-              <a:t>дай нам (хліб небесний),</a:t>
+              <a:t>Дай нам, дай нам,</a:t>
             </a:r>
             <a:endParaRPr lang="en-US" sz="4800" dirty="0"/>
           </a:p>

</xml_diff>